<commit_message>
feat(pptx): brand the default deck template in Illini colors
templates/gies.pptx was a stock 4:3 Office placeholder, so every deck the
Work-mode agent built came out unbranded. It is now 16:9 with an Illinois
theme: a blue title field, an orange section header, blue headings over an
orange rule on the content layouts, and orange bullet glyphs. Colors match
the app's own tokens in client/src/style.css.

The theme's accent1/dk2 carry the palette, so charts and tables inherit it
rather than needing per-shape styling.

scripts/build_gies_template.py is the source of the binary - it builds from
python-pptx's stock master, so re-running it is idempotent. Layout names are
deliberately unchanged, since the MCP prompt and design_layouts both address
layouts by name.
</commit_message>
<xml_diff>
--- a/infra/pptx-mcp/templates/gies.pptx
+++ b/infra/pptx-mcp/templates/gies.pptx
@@ -4,7 +4,7 @@
   <p:sldMasterIdLst>
     <p:sldMasterId id="2147483648" r:id="rId1"/>
   </p:sldMasterIdLst>
-  <p:sldSz cx="9144000" cy="6858000" type="screen4x3"/>
+  <p:sldSz cx="12192000" cy="6858000" type="screen4x3"/>
   <p:notesSz cx="6858000" cy="9144000"/>
   <p:defaultTextStyle>
     <a:defPPr>
@@ -123,23 +123,85 @@
       </p:grpSpPr>
       <p:sp>
         <p:nvSpPr>
-          <p:cNvPr id="2" name="Title 1"/>
-          <p:cNvSpPr>
-            <a:spLocks noGrp="1"/>
-          </p:cNvSpPr>
-          <p:nvPr>
-            <p:ph type="ctrTitle"/>
-          </p:nvPr>
+          <p:cNvPr id="901" name="Field"/>
+          <p:cNvSpPr/>
+          <p:nvPr userDrawn="1"/>
         </p:nvSpPr>
         <p:spPr>
           <a:xfrm>
-            <a:off x="685800" y="2130425"/>
-            <a:ext cx="7772400" cy="1470025"/>
+            <a:off x="0" y="0"/>
+            <a:ext cx="12192000" cy="6858000"/>
+          </a:xfrm>
+          <a:prstGeom prst="rect">
+            <a:avLst/>
+          </a:prstGeom>
+          <a:solidFill>
+            <a:srgbClr val="13294B"/>
+          </a:solidFill>
+          <a:ln>
+            <a:noFill/>
+          </a:ln>
+        </p:spPr>
+        <p:txBody>
+          <a:bodyPr/>
+          <a:lstStyle/>
+          <a:p/>
+        </p:txBody>
+      </p:sp>
+      <p:sp>
+        <p:nvSpPr>
+          <p:cNvPr id="902" name="Accent rule"/>
+          <p:cNvSpPr/>
+          <p:nvPr userDrawn="1"/>
+        </p:nvSpPr>
+        <p:spPr>
+          <a:xfrm>
+            <a:off x="914400" y="3700000"/>
+            <a:ext cx="2600000" cy="74000"/>
+          </a:xfrm>
+          <a:prstGeom prst="rect">
+            <a:avLst/>
+          </a:prstGeom>
+          <a:solidFill>
+            <a:srgbClr val="FF5F05"/>
+          </a:solidFill>
+          <a:ln>
+            <a:noFill/>
+          </a:ln>
+        </p:spPr>
+        <p:txBody>
+          <a:bodyPr/>
+          <a:lstStyle/>
+          <a:p/>
+        </p:txBody>
+      </p:sp>
+      <p:sp>
+        <p:nvSpPr>
+          <p:cNvPr id="2" name="Title 1"/>
+          <p:cNvSpPr>
+            <a:spLocks noGrp="1"/>
+          </p:cNvSpPr>
+          <p:nvPr>
+            <p:ph type="ctrTitle"/>
+          </p:nvPr>
+        </p:nvSpPr>
+        <p:spPr>
+          <a:xfrm>
+            <a:off x="914400" y="2300000"/>
+            <a:ext cx="9000000" cy="1300000"/>
           </a:xfrm>
         </p:spPr>
         <p:txBody>
           <a:bodyPr/>
-          <a:lstStyle/>
+          <a:lstStyle>
+            <a:lvl1pPr algn="l">
+              <a:defRPr>
+                <a:solidFill>
+                  <a:srgbClr val="FFFFFF"/>
+                </a:solidFill>
+              </a:defRPr>
+            </a:lvl1pPr>
+          </a:lstStyle>
           <a:p>
             <a:r>
               <a:rPr lang="en-US" smtClean="0"/>
@@ -161,8 +223,8 @@
         </p:nvSpPr>
         <p:spPr>
           <a:xfrm>
-            <a:off x="1371600" y="3886200"/>
-            <a:ext cx="6400800" cy="1752600"/>
+            <a:off x="914400" y="3950000"/>
+            <a:ext cx="9000000" cy="900000"/>
           </a:xfrm>
         </p:spPr>
         <p:txBody>
@@ -258,6 +320,13 @@
                 </a:solidFill>
               </a:defRPr>
             </a:lvl9pPr>
+            <a:lvl1pPr algn="l">
+              <a:defRPr>
+                <a:solidFill>
+                  <a:srgbClr val="FFFFFF"/>
+                </a:solidFill>
+              </a:defRPr>
+            </a:lvl1pPr>
           </a:lstStyle>
           <a:p>
             <a:r>
@@ -281,7 +350,15 @@
         <p:spPr/>
         <p:txBody>
           <a:bodyPr/>
-          <a:lstStyle/>
+          <a:lstStyle>
+            <a:lvl1pPr algn="l">
+              <a:defRPr>
+                <a:solidFill>
+                  <a:srgbClr val="FFFFFF"/>
+                </a:solidFill>
+              </a:defRPr>
+            </a:lvl1pPr>
+          </a:lstStyle>
           <a:p>
             <a:fld id="{5BCAD085-E8A6-8845-BD4E-CB4CCA059FC4}" type="datetimeFigureOut">
               <a:rPr lang="en-US" smtClean="0"/>
@@ -304,7 +381,15 @@
         <p:spPr/>
         <p:txBody>
           <a:bodyPr/>
-          <a:lstStyle/>
+          <a:lstStyle>
+            <a:lvl1pPr algn="l">
+              <a:defRPr>
+                <a:solidFill>
+                  <a:srgbClr val="FFFFFF"/>
+                </a:solidFill>
+              </a:defRPr>
+            </a:lvl1pPr>
+          </a:lstStyle>
           <a:p>
             <a:endParaRPr lang="en-US"/>
           </a:p>
@@ -323,7 +408,15 @@
         <p:spPr/>
         <p:txBody>
           <a:bodyPr/>
-          <a:lstStyle/>
+          <a:lstStyle>
+            <a:lvl1pPr algn="l">
+              <a:defRPr>
+                <a:solidFill>
+                  <a:srgbClr val="FFFFFF"/>
+                </a:solidFill>
+              </a:defRPr>
+            </a:lvl1pPr>
+          </a:lstStyle>
           <a:p>
             <a:fld id="{C1FF6DA9-008F-8B48-92A6-B652298478BF}" type="slidenum">
               <a:rPr lang="en-US" smtClean="0"/>
@@ -365,6 +458,33 @@
       </p:grpSpPr>
       <p:sp>
         <p:nvSpPr>
+          <p:cNvPr id="904" name="Accent rule"/>
+          <p:cNvSpPr/>
+          <p:nvPr userDrawn="1"/>
+        </p:nvSpPr>
+        <p:spPr>
+          <a:xfrm>
+            <a:off x="914400" y="1430000"/>
+            <a:ext cx="2200000" cy="60000"/>
+          </a:xfrm>
+          <a:prstGeom prst="rect">
+            <a:avLst/>
+          </a:prstGeom>
+          <a:solidFill>
+            <a:srgbClr val="FF5F05"/>
+          </a:solidFill>
+          <a:ln>
+            <a:noFill/>
+          </a:ln>
+        </p:spPr>
+        <p:txBody>
+          <a:bodyPr/>
+          <a:lstStyle/>
+          <a:p/>
+        </p:txBody>
+      </p:sp>
+      <p:sp>
+        <p:nvSpPr>
           <p:cNvPr id="2" name="Title 1"/>
           <p:cNvSpPr>
             <a:spLocks noGrp="1"/>
@@ -535,18 +655,45 @@
       </p:grpSpPr>
       <p:sp>
         <p:nvSpPr>
-          <p:cNvPr id="2" name="Vertical Title 1"/>
-          <p:cNvSpPr>
-            <a:spLocks noGrp="1"/>
-          </p:cNvSpPr>
-          <p:nvPr>
-            <p:ph type="title" orient="vert"/>
-          </p:nvPr>
+          <p:cNvPr id="904" name="Accent rule"/>
+          <p:cNvSpPr/>
+          <p:nvPr userDrawn="1"/>
         </p:nvSpPr>
         <p:spPr>
           <a:xfrm>
-            <a:off x="6629400" y="274638"/>
-            <a:ext cx="2057400" cy="5851525"/>
+            <a:off x="914400" y="1430000"/>
+            <a:ext cx="2200000" cy="60000"/>
+          </a:xfrm>
+          <a:prstGeom prst="rect">
+            <a:avLst/>
+          </a:prstGeom>
+          <a:solidFill>
+            <a:srgbClr val="FF5F05"/>
+          </a:solidFill>
+          <a:ln>
+            <a:noFill/>
+          </a:ln>
+        </p:spPr>
+        <p:txBody>
+          <a:bodyPr/>
+          <a:lstStyle/>
+          <a:p/>
+        </p:txBody>
+      </p:sp>
+      <p:sp>
+        <p:nvSpPr>
+          <p:cNvPr id="2" name="Vertical Title 1"/>
+          <p:cNvSpPr>
+            <a:spLocks noGrp="1"/>
+          </p:cNvSpPr>
+          <p:nvPr>
+            <p:ph type="title" orient="vert"/>
+          </p:nvPr>
+        </p:nvSpPr>
+        <p:spPr>
+          <a:xfrm>
+            <a:off x="8839200" y="274638"/>
+            <a:ext cx="2743200" cy="5851525"/>
           </a:xfrm>
         </p:spPr>
         <p:txBody>
@@ -573,8 +720,8 @@
         </p:nvSpPr>
         <p:spPr>
           <a:xfrm>
-            <a:off x="457200" y="274638"/>
-            <a:ext cx="6019800" cy="5851525"/>
+            <a:off x="609600" y="274638"/>
+            <a:ext cx="8026400" cy="5851525"/>
           </a:xfrm>
         </p:spPr>
         <p:txBody>
@@ -715,6 +862,33 @@
       </p:grpSpPr>
       <p:sp>
         <p:nvSpPr>
+          <p:cNvPr id="904" name="Accent rule"/>
+          <p:cNvSpPr/>
+          <p:nvPr userDrawn="1"/>
+        </p:nvSpPr>
+        <p:spPr>
+          <a:xfrm>
+            <a:off x="914400" y="1430000"/>
+            <a:ext cx="2200000" cy="60000"/>
+          </a:xfrm>
+          <a:prstGeom prst="rect">
+            <a:avLst/>
+          </a:prstGeom>
+          <a:solidFill>
+            <a:srgbClr val="FF5F05"/>
+          </a:solidFill>
+          <a:ln>
+            <a:noFill/>
+          </a:ln>
+        </p:spPr>
+        <p:txBody>
+          <a:bodyPr/>
+          <a:lstStyle/>
+          <a:p/>
+        </p:txBody>
+      </p:sp>
+      <p:sp>
+        <p:nvSpPr>
           <p:cNvPr id="2" name="Title 1"/>
           <p:cNvSpPr>
             <a:spLocks noGrp="1"/>
@@ -885,18 +1059,45 @@
       </p:grpSpPr>
       <p:sp>
         <p:nvSpPr>
-          <p:cNvPr id="2" name="Title 1"/>
-          <p:cNvSpPr>
-            <a:spLocks noGrp="1"/>
-          </p:cNvSpPr>
-          <p:nvPr>
-            <p:ph type="title"/>
-          </p:nvPr>
+          <p:cNvPr id="903" name="Field"/>
+          <p:cNvSpPr/>
+          <p:nvPr userDrawn="1"/>
         </p:nvSpPr>
         <p:spPr>
           <a:xfrm>
-            <a:off x="722313" y="4406900"/>
-            <a:ext cx="7772400" cy="1362075"/>
+            <a:off x="0" y="0"/>
+            <a:ext cx="12192000" cy="6858000"/>
+          </a:xfrm>
+          <a:prstGeom prst="rect">
+            <a:avLst/>
+          </a:prstGeom>
+          <a:solidFill>
+            <a:srgbClr val="FF5F05"/>
+          </a:solidFill>
+          <a:ln>
+            <a:noFill/>
+          </a:ln>
+        </p:spPr>
+        <p:txBody>
+          <a:bodyPr/>
+          <a:lstStyle/>
+          <a:p/>
+        </p:txBody>
+      </p:sp>
+      <p:sp>
+        <p:nvSpPr>
+          <p:cNvPr id="2" name="Title 1"/>
+          <p:cNvSpPr>
+            <a:spLocks noGrp="1"/>
+          </p:cNvSpPr>
+          <p:nvPr>
+            <p:ph type="title"/>
+          </p:nvPr>
+        </p:nvSpPr>
+        <p:spPr>
+          <a:xfrm>
+            <a:off x="963084" y="4406900"/>
+            <a:ext cx="10363200" cy="1362075"/>
           </a:xfrm>
         </p:spPr>
         <p:txBody>
@@ -905,6 +1106,13 @@
             <a:lvl1pPr algn="l">
               <a:defRPr sz="4000" b="1" cap="all"/>
             </a:lvl1pPr>
+            <a:lvl1pPr algn="l">
+              <a:defRPr>
+                <a:solidFill>
+                  <a:srgbClr val="FFFFFF"/>
+                </a:solidFill>
+              </a:defRPr>
+            </a:lvl1pPr>
           </a:lstStyle>
           <a:p>
             <a:r>
@@ -927,8 +1135,8 @@
         </p:nvSpPr>
         <p:spPr>
           <a:xfrm>
-            <a:off x="722313" y="2906713"/>
-            <a:ext cx="7772400" cy="1500187"/>
+            <a:off x="963084" y="2906713"/>
+            <a:ext cx="10363200" cy="1500187"/>
           </a:xfrm>
         </p:spPr>
         <p:txBody>
@@ -1024,6 +1232,13 @@
                 </a:solidFill>
               </a:defRPr>
             </a:lvl9pPr>
+            <a:lvl1pPr algn="l">
+              <a:defRPr>
+                <a:solidFill>
+                  <a:srgbClr val="FFFFFF"/>
+                </a:solidFill>
+              </a:defRPr>
+            </a:lvl1pPr>
           </a:lstStyle>
           <a:p>
             <a:pPr lvl="0"/>
@@ -1047,7 +1262,15 @@
         <p:spPr/>
         <p:txBody>
           <a:bodyPr/>
-          <a:lstStyle/>
+          <a:lstStyle>
+            <a:lvl1pPr algn="l">
+              <a:defRPr>
+                <a:solidFill>
+                  <a:srgbClr val="FFFFFF"/>
+                </a:solidFill>
+              </a:defRPr>
+            </a:lvl1pPr>
+          </a:lstStyle>
           <a:p>
             <a:fld id="{5BCAD085-E8A6-8845-BD4E-CB4CCA059FC4}" type="datetimeFigureOut">
               <a:rPr lang="en-US" smtClean="0"/>
@@ -1070,7 +1293,15 @@
         <p:spPr/>
         <p:txBody>
           <a:bodyPr/>
-          <a:lstStyle/>
+          <a:lstStyle>
+            <a:lvl1pPr algn="l">
+              <a:defRPr>
+                <a:solidFill>
+                  <a:srgbClr val="FFFFFF"/>
+                </a:solidFill>
+              </a:defRPr>
+            </a:lvl1pPr>
+          </a:lstStyle>
           <a:p>
             <a:endParaRPr lang="en-US"/>
           </a:p>
@@ -1089,7 +1320,15 @@
         <p:spPr/>
         <p:txBody>
           <a:bodyPr/>
-          <a:lstStyle/>
+          <a:lstStyle>
+            <a:lvl1pPr algn="l">
+              <a:defRPr>
+                <a:solidFill>
+                  <a:srgbClr val="FFFFFF"/>
+                </a:solidFill>
+              </a:defRPr>
+            </a:lvl1pPr>
+          </a:lstStyle>
           <a:p>
             <a:fld id="{C1FF6DA9-008F-8B48-92A6-B652298478BF}" type="slidenum">
               <a:rPr lang="en-US" smtClean="0"/>
@@ -1131,41 +1370,68 @@
       </p:grpSpPr>
       <p:sp>
         <p:nvSpPr>
-          <p:cNvPr id="2" name="Title 1"/>
-          <p:cNvSpPr>
-            <a:spLocks noGrp="1"/>
-          </p:cNvSpPr>
-          <p:nvPr>
-            <p:ph type="title"/>
-          </p:nvPr>
-        </p:nvSpPr>
-        <p:spPr/>
-        <p:txBody>
-          <a:bodyPr/>
-          <a:lstStyle/>
-          <a:p>
-            <a:r>
-              <a:rPr lang="en-US" smtClean="0"/>
-              <a:t>Click to edit Master title style</a:t>
-            </a:r>
-            <a:endParaRPr lang="en-US"/>
-          </a:p>
-        </p:txBody>
-      </p:sp>
-      <p:sp>
-        <p:nvSpPr>
-          <p:cNvPr id="3" name="Content Placeholder 2"/>
-          <p:cNvSpPr>
-            <a:spLocks noGrp="1"/>
-          </p:cNvSpPr>
-          <p:nvPr>
-            <p:ph sz="half" idx="1"/>
-          </p:nvPr>
+          <p:cNvPr id="904" name="Accent rule"/>
+          <p:cNvSpPr/>
+          <p:nvPr userDrawn="1"/>
         </p:nvSpPr>
         <p:spPr>
           <a:xfrm>
-            <a:off x="457200" y="1600200"/>
-            <a:ext cx="4038600" cy="4525963"/>
+            <a:off x="914400" y="1430000"/>
+            <a:ext cx="2200000" cy="60000"/>
+          </a:xfrm>
+          <a:prstGeom prst="rect">
+            <a:avLst/>
+          </a:prstGeom>
+          <a:solidFill>
+            <a:srgbClr val="FF5F05"/>
+          </a:solidFill>
+          <a:ln>
+            <a:noFill/>
+          </a:ln>
+        </p:spPr>
+        <p:txBody>
+          <a:bodyPr/>
+          <a:lstStyle/>
+          <a:p/>
+        </p:txBody>
+      </p:sp>
+      <p:sp>
+        <p:nvSpPr>
+          <p:cNvPr id="2" name="Title 1"/>
+          <p:cNvSpPr>
+            <a:spLocks noGrp="1"/>
+          </p:cNvSpPr>
+          <p:nvPr>
+            <p:ph type="title"/>
+          </p:nvPr>
+        </p:nvSpPr>
+        <p:spPr/>
+        <p:txBody>
+          <a:bodyPr/>
+          <a:lstStyle/>
+          <a:p>
+            <a:r>
+              <a:rPr lang="en-US" smtClean="0"/>
+              <a:t>Click to edit Master title style</a:t>
+            </a:r>
+            <a:endParaRPr lang="en-US"/>
+          </a:p>
+        </p:txBody>
+      </p:sp>
+      <p:sp>
+        <p:nvSpPr>
+          <p:cNvPr id="3" name="Content Placeholder 2"/>
+          <p:cNvSpPr>
+            <a:spLocks noGrp="1"/>
+          </p:cNvSpPr>
+          <p:nvPr>
+            <p:ph sz="half" idx="1"/>
+          </p:nvPr>
+        </p:nvSpPr>
+        <p:spPr>
+          <a:xfrm>
+            <a:off x="609600" y="1600200"/>
+            <a:ext cx="5384800" cy="4525963"/>
           </a:xfrm>
         </p:spPr>
         <p:txBody>
@@ -1249,8 +1515,8 @@
         </p:nvSpPr>
         <p:spPr>
           <a:xfrm>
-            <a:off x="4648200" y="1600200"/>
-            <a:ext cx="4038600" cy="4525963"/>
+            <a:off x="6197600" y="1600200"/>
+            <a:ext cx="5384800" cy="4525963"/>
           </a:xfrm>
         </p:spPr>
         <p:txBody>
@@ -1419,6 +1685,33 @@
       </p:grpSpPr>
       <p:sp>
         <p:nvSpPr>
+          <p:cNvPr id="904" name="Accent rule"/>
+          <p:cNvSpPr/>
+          <p:nvPr userDrawn="1"/>
+        </p:nvSpPr>
+        <p:spPr>
+          <a:xfrm>
+            <a:off x="914400" y="1430000"/>
+            <a:ext cx="2200000" cy="60000"/>
+          </a:xfrm>
+          <a:prstGeom prst="rect">
+            <a:avLst/>
+          </a:prstGeom>
+          <a:solidFill>
+            <a:srgbClr val="FF5F05"/>
+          </a:solidFill>
+          <a:ln>
+            <a:noFill/>
+          </a:ln>
+        </p:spPr>
+        <p:txBody>
+          <a:bodyPr/>
+          <a:lstStyle/>
+          <a:p/>
+        </p:txBody>
+      </p:sp>
+      <p:sp>
+        <p:nvSpPr>
           <p:cNvPr id="2" name="Title 1"/>
           <p:cNvSpPr>
             <a:spLocks noGrp="1"/>
@@ -1456,8 +1749,8 @@
         </p:nvSpPr>
         <p:spPr>
           <a:xfrm>
-            <a:off x="457200" y="1535113"/>
-            <a:ext cx="4040188" cy="639762"/>
+            <a:off x="609600" y="1535113"/>
+            <a:ext cx="5386917" cy="639762"/>
           </a:xfrm>
         </p:spPr>
         <p:txBody>
@@ -1521,8 +1814,8 @@
         </p:nvSpPr>
         <p:spPr>
           <a:xfrm>
-            <a:off x="457200" y="2174875"/>
-            <a:ext cx="4040188" cy="3951288"/>
+            <a:off x="609600" y="2174875"/>
+            <a:ext cx="5386917" cy="3951288"/>
           </a:xfrm>
         </p:spPr>
         <p:txBody>
@@ -1606,8 +1899,8 @@
         </p:nvSpPr>
         <p:spPr>
           <a:xfrm>
-            <a:off x="4645025" y="1535113"/>
-            <a:ext cx="4041775" cy="639762"/>
+            <a:off x="6193366" y="1535113"/>
+            <a:ext cx="5389033" cy="639762"/>
           </a:xfrm>
         </p:spPr>
         <p:txBody>
@@ -1671,8 +1964,8 @@
         </p:nvSpPr>
         <p:spPr>
           <a:xfrm>
-            <a:off x="4645025" y="2174875"/>
-            <a:ext cx="4041775" cy="3951288"/>
+            <a:off x="6193366" y="2174875"/>
+            <a:ext cx="5389033" cy="3951288"/>
           </a:xfrm>
         </p:spPr>
         <p:txBody>
@@ -1841,6 +2134,33 @@
       </p:grpSpPr>
       <p:sp>
         <p:nvSpPr>
+          <p:cNvPr id="904" name="Accent rule"/>
+          <p:cNvSpPr/>
+          <p:nvPr userDrawn="1"/>
+        </p:nvSpPr>
+        <p:spPr>
+          <a:xfrm>
+            <a:off x="914400" y="1430000"/>
+            <a:ext cx="2200000" cy="60000"/>
+          </a:xfrm>
+          <a:prstGeom prst="rect">
+            <a:avLst/>
+          </a:prstGeom>
+          <a:solidFill>
+            <a:srgbClr val="FF5F05"/>
+          </a:solidFill>
+          <a:ln>
+            <a:noFill/>
+          </a:ln>
+        </p:spPr>
+        <p:txBody>
+          <a:bodyPr/>
+          <a:lstStyle/>
+          <a:p/>
+        </p:txBody>
+      </p:sp>
+      <p:sp>
+        <p:nvSpPr>
           <p:cNvPr id="2" name="Title 1"/>
           <p:cNvSpPr>
             <a:spLocks noGrp="1"/>
@@ -2054,18 +2374,45 @@
       </p:grpSpPr>
       <p:sp>
         <p:nvSpPr>
-          <p:cNvPr id="2" name="Title 1"/>
-          <p:cNvSpPr>
-            <a:spLocks noGrp="1"/>
-          </p:cNvSpPr>
-          <p:nvPr>
-            <p:ph type="title"/>
-          </p:nvPr>
+          <p:cNvPr id="904" name="Accent rule"/>
+          <p:cNvSpPr/>
+          <p:nvPr userDrawn="1"/>
         </p:nvSpPr>
         <p:spPr>
           <a:xfrm>
-            <a:off x="457200" y="273050"/>
-            <a:ext cx="3008313" cy="1162050"/>
+            <a:off x="914400" y="1430000"/>
+            <a:ext cx="2200000" cy="60000"/>
+          </a:xfrm>
+          <a:prstGeom prst="rect">
+            <a:avLst/>
+          </a:prstGeom>
+          <a:solidFill>
+            <a:srgbClr val="FF5F05"/>
+          </a:solidFill>
+          <a:ln>
+            <a:noFill/>
+          </a:ln>
+        </p:spPr>
+        <p:txBody>
+          <a:bodyPr/>
+          <a:lstStyle/>
+          <a:p/>
+        </p:txBody>
+      </p:sp>
+      <p:sp>
+        <p:nvSpPr>
+          <p:cNvPr id="2" name="Title 1"/>
+          <p:cNvSpPr>
+            <a:spLocks noGrp="1"/>
+          </p:cNvSpPr>
+          <p:nvPr>
+            <p:ph type="title"/>
+          </p:nvPr>
+        </p:nvSpPr>
+        <p:spPr>
+          <a:xfrm>
+            <a:off x="609600" y="273050"/>
+            <a:ext cx="4011084" cy="1162050"/>
           </a:xfrm>
         </p:spPr>
         <p:txBody>
@@ -2096,8 +2443,8 @@
         </p:nvSpPr>
         <p:spPr>
           <a:xfrm>
-            <a:off x="3575050" y="273050"/>
-            <a:ext cx="5111750" cy="5853113"/>
+            <a:off x="4766733" y="273050"/>
+            <a:ext cx="6815666" cy="5853113"/>
           </a:xfrm>
         </p:spPr>
         <p:txBody>
@@ -2181,8 +2528,8 @@
         </p:nvSpPr>
         <p:spPr>
           <a:xfrm>
-            <a:off x="457200" y="1435100"/>
-            <a:ext cx="3008313" cy="4691063"/>
+            <a:off x="609600" y="1435100"/>
+            <a:ext cx="4011084" cy="4691063"/>
           </a:xfrm>
         </p:spPr>
         <p:txBody>
@@ -2331,18 +2678,45 @@
       </p:grpSpPr>
       <p:sp>
         <p:nvSpPr>
-          <p:cNvPr id="2" name="Title 1"/>
-          <p:cNvSpPr>
-            <a:spLocks noGrp="1"/>
-          </p:cNvSpPr>
-          <p:nvPr>
-            <p:ph type="title"/>
-          </p:nvPr>
+          <p:cNvPr id="904" name="Accent rule"/>
+          <p:cNvSpPr/>
+          <p:nvPr userDrawn="1"/>
         </p:nvSpPr>
         <p:spPr>
           <a:xfrm>
-            <a:off x="1792288" y="4800600"/>
-            <a:ext cx="5486400" cy="566738"/>
+            <a:off x="914400" y="1430000"/>
+            <a:ext cx="2200000" cy="60000"/>
+          </a:xfrm>
+          <a:prstGeom prst="rect">
+            <a:avLst/>
+          </a:prstGeom>
+          <a:solidFill>
+            <a:srgbClr val="FF5F05"/>
+          </a:solidFill>
+          <a:ln>
+            <a:noFill/>
+          </a:ln>
+        </p:spPr>
+        <p:txBody>
+          <a:bodyPr/>
+          <a:lstStyle/>
+          <a:p/>
+        </p:txBody>
+      </p:sp>
+      <p:sp>
+        <p:nvSpPr>
+          <p:cNvPr id="2" name="Title 1"/>
+          <p:cNvSpPr>
+            <a:spLocks noGrp="1"/>
+          </p:cNvSpPr>
+          <p:nvPr>
+            <p:ph type="title"/>
+          </p:nvPr>
+        </p:nvSpPr>
+        <p:spPr>
+          <a:xfrm>
+            <a:off x="2389717" y="4800600"/>
+            <a:ext cx="7315200" cy="566738"/>
           </a:xfrm>
         </p:spPr>
         <p:txBody>
@@ -2373,8 +2747,8 @@
         </p:nvSpPr>
         <p:spPr>
           <a:xfrm>
-            <a:off x="1792288" y="612775"/>
-            <a:ext cx="5486400" cy="4114800"/>
+            <a:off x="2389717" y="612775"/>
+            <a:ext cx="7315200" cy="4114800"/>
           </a:xfrm>
         </p:spPr>
         <p:txBody>
@@ -2434,8 +2808,8 @@
         </p:nvSpPr>
         <p:spPr>
           <a:xfrm>
-            <a:off x="1792288" y="5367338"/>
-            <a:ext cx="5486400" cy="804862"/>
+            <a:off x="2389717" y="5367338"/>
+            <a:ext cx="7315200" cy="804862"/>
           </a:xfrm>
         </p:spPr>
         <p:txBody>
@@ -2589,18 +2963,45 @@
       </p:grpSpPr>
       <p:sp>
         <p:nvSpPr>
-          <p:cNvPr id="2" name="Title Placeholder 1"/>
-          <p:cNvSpPr>
-            <a:spLocks noGrp="1"/>
-          </p:cNvSpPr>
-          <p:nvPr>
-            <p:ph type="title"/>
-          </p:nvPr>
+          <p:cNvPr id="900" name="Accent rule"/>
+          <p:cNvSpPr/>
+          <p:nvPr userDrawn="1"/>
         </p:nvSpPr>
         <p:spPr>
           <a:xfrm>
-            <a:off x="457200" y="274638"/>
-            <a:ext cx="8229600" cy="1143000"/>
+            <a:off x="914400" y="1430000"/>
+            <a:ext cx="2200000" cy="60000"/>
+          </a:xfrm>
+          <a:prstGeom prst="rect">
+            <a:avLst/>
+          </a:prstGeom>
+          <a:solidFill>
+            <a:srgbClr val="FF5F05"/>
+          </a:solidFill>
+          <a:ln>
+            <a:noFill/>
+          </a:ln>
+        </p:spPr>
+        <p:txBody>
+          <a:bodyPr/>
+          <a:lstStyle/>
+          <a:p/>
+        </p:txBody>
+      </p:sp>
+      <p:sp>
+        <p:nvSpPr>
+          <p:cNvPr id="2" name="Title Placeholder 1"/>
+          <p:cNvSpPr>
+            <a:spLocks noGrp="1"/>
+          </p:cNvSpPr>
+          <p:nvPr>
+            <p:ph type="title"/>
+          </p:nvPr>
+        </p:nvSpPr>
+        <p:spPr>
+          <a:xfrm>
+            <a:off x="609600" y="274638"/>
+            <a:ext cx="10972800" cy="1143000"/>
           </a:xfrm>
           <a:prstGeom prst="rect">
             <a:avLst/>
@@ -2632,8 +3033,8 @@
         </p:nvSpPr>
         <p:spPr>
           <a:xfrm>
-            <a:off x="457200" y="1600200"/>
-            <a:ext cx="8229600" cy="4525963"/>
+            <a:off x="609600" y="1600200"/>
+            <a:ext cx="10972800" cy="4525963"/>
           </a:xfrm>
           <a:prstGeom prst="rect">
             <a:avLst/>
@@ -2694,8 +3095,8 @@
         </p:nvSpPr>
         <p:spPr>
           <a:xfrm>
-            <a:off x="457200" y="6356350"/>
-            <a:ext cx="2133600" cy="365125"/>
+            <a:off x="609600" y="6356350"/>
+            <a:ext cx="2844800" cy="365125"/>
           </a:xfrm>
           <a:prstGeom prst="rect">
             <a:avLst/>
@@ -2735,8 +3136,8 @@
         </p:nvSpPr>
         <p:spPr>
           <a:xfrm>
-            <a:off x="3124200" y="6356350"/>
-            <a:ext cx="2895600" cy="365125"/>
+            <a:off x="4165600" y="6356350"/>
+            <a:ext cx="3860800" cy="365125"/>
           </a:xfrm>
           <a:prstGeom prst="rect">
             <a:avLst/>
@@ -2772,8 +3173,8 @@
         </p:nvSpPr>
         <p:spPr>
           <a:xfrm>
-            <a:off x="6553200" y="6356350"/>
-            <a:ext cx="2133600" cy="365125"/>
+            <a:off x="8737600" y="6356350"/>
+            <a:ext cx="2844800" cy="365125"/>
           </a:xfrm>
           <a:prstGeom prst="rect">
             <a:avLst/>
@@ -2824,14 +3225,14 @@
   </p:sldLayoutIdLst>
   <p:txStyles>
     <p:titleStyle>
-      <a:lvl1pPr algn="ctr" defTabSz="457200" rtl="0" eaLnBrk="1" latinLnBrk="0" hangingPunct="1">
+      <a:lvl1pPr algn="l" defTabSz="457200" rtl="0" eaLnBrk="1" latinLnBrk="0" hangingPunct="1">
         <a:spcBef>
           <a:spcPct val="0"/>
         </a:spcBef>
         <a:buNone/>
-        <a:defRPr sz="4400" kern="1200">
+        <a:defRPr sz="3600" kern="1200" b="1">
           <a:solidFill>
-            <a:schemeClr val="tx1"/>
+            <a:srgbClr val="13294B"/>
           </a:solidFill>
           <a:latin typeface="+mj-lt"/>
           <a:ea typeface="+mj-ea"/>
@@ -2841,14 +3242,17 @@
     </p:titleStyle>
     <p:bodyStyle>
       <a:lvl1pPr marL="342900" indent="-342900" algn="l" defTabSz="457200" rtl="0" eaLnBrk="1" latinLnBrk="0" hangingPunct="1">
+        <a:buClr>
+          <a:srgbClr val="FF5F05"/>
+        </a:buClr>
         <a:spcBef>
           <a:spcPct val="20000"/>
         </a:spcBef>
         <a:buFont typeface="Arial"/>
         <a:buChar char="•"/>
-        <a:defRPr sz="3200" kern="1200">
+        <a:defRPr sz="2000" kern="1200">
           <a:solidFill>
-            <a:schemeClr val="tx1"/>
+            <a:srgbClr val="1D2733"/>
           </a:solidFill>
           <a:latin typeface="+mn-lt"/>
           <a:ea typeface="+mn-ea"/>
@@ -2856,14 +3260,17 @@
         </a:defRPr>
       </a:lvl1pPr>
       <a:lvl2pPr marL="742950" indent="-285750" algn="l" defTabSz="457200" rtl="0" eaLnBrk="1" latinLnBrk="0" hangingPunct="1">
+        <a:buClr>
+          <a:srgbClr val="FF5F05"/>
+        </a:buClr>
         <a:spcBef>
           <a:spcPct val="20000"/>
         </a:spcBef>
         <a:buFont typeface="Arial"/>
         <a:buChar char="–"/>
-        <a:defRPr sz="2800" kern="1200">
+        <a:defRPr sz="1800" kern="1200">
           <a:solidFill>
-            <a:schemeClr val="tx1"/>
+            <a:srgbClr val="1D2733"/>
           </a:solidFill>
           <a:latin typeface="+mn-lt"/>
           <a:ea typeface="+mn-ea"/>
@@ -2871,14 +3278,17 @@
         </a:defRPr>
       </a:lvl2pPr>
       <a:lvl3pPr marL="1143000" indent="-228600" algn="l" defTabSz="457200" rtl="0" eaLnBrk="1" latinLnBrk="0" hangingPunct="1">
+        <a:buClr>
+          <a:srgbClr val="FF5F05"/>
+        </a:buClr>
         <a:spcBef>
           <a:spcPct val="20000"/>
         </a:spcBef>
         <a:buFont typeface="Arial"/>
         <a:buChar char="•"/>
-        <a:defRPr sz="2400" kern="1200">
+        <a:defRPr sz="1600" kern="1200">
           <a:solidFill>
-            <a:schemeClr val="tx1"/>
+            <a:srgbClr val="1D2733"/>
           </a:solidFill>
           <a:latin typeface="+mn-lt"/>
           <a:ea typeface="+mn-ea"/>
@@ -2886,14 +3296,17 @@
         </a:defRPr>
       </a:lvl3pPr>
       <a:lvl4pPr marL="1600200" indent="-228600" algn="l" defTabSz="457200" rtl="0" eaLnBrk="1" latinLnBrk="0" hangingPunct="1">
+        <a:buClr>
+          <a:srgbClr val="FF5F05"/>
+        </a:buClr>
         <a:spcBef>
           <a:spcPct val="20000"/>
         </a:spcBef>
         <a:buFont typeface="Arial"/>
         <a:buChar char="–"/>
-        <a:defRPr sz="2000" kern="1200">
+        <a:defRPr sz="1400" kern="1200">
           <a:solidFill>
-            <a:schemeClr val="tx1"/>
+            <a:srgbClr val="1D2733"/>
           </a:solidFill>
           <a:latin typeface="+mn-lt"/>
           <a:ea typeface="+mn-ea"/>
@@ -2901,14 +3314,17 @@
         </a:defRPr>
       </a:lvl4pPr>
       <a:lvl5pPr marL="2057400" indent="-228600" algn="l" defTabSz="457200" rtl="0" eaLnBrk="1" latinLnBrk="0" hangingPunct="1">
+        <a:buClr>
+          <a:srgbClr val="FF5F05"/>
+        </a:buClr>
         <a:spcBef>
           <a:spcPct val="20000"/>
         </a:spcBef>
         <a:buFont typeface="Arial"/>
         <a:buChar char="»"/>
-        <a:defRPr sz="2000" kern="1200">
+        <a:defRPr sz="1400" kern="1200">
           <a:solidFill>
-            <a:schemeClr val="tx1"/>
+            <a:srgbClr val="1D2733"/>
           </a:solidFill>
           <a:latin typeface="+mn-lt"/>
           <a:ea typeface="+mn-ea"/>
@@ -3078,47 +3494,47 @@
 <file path=ppt/theme/theme1.xml><?xml version="1.0" encoding="utf-8"?>
 <a:theme xmlns:a="http://schemas.openxmlformats.org/drawingml/2006/main" name="Office Theme">
   <a:themeElements>
-    <a:clrScheme name="Office">
+    <a:clrScheme name="Illinois">
       <a:dk1>
-        <a:sysClr val="windowText" lastClr="000000"/>
+        <a:srgbClr val="1D2733"/>
       </a:dk1>
       <a:lt1>
-        <a:sysClr val="window" lastClr="FFFFFF"/>
+        <a:srgbClr val="FFFFFF"/>
       </a:lt1>
       <a:dk2>
-        <a:srgbClr val="1F497D"/>
+        <a:srgbClr val="13294B"/>
       </a:dk2>
       <a:lt2>
-        <a:srgbClr val="EEECE1"/>
+        <a:srgbClr val="F2F4F7"/>
       </a:lt2>
       <a:accent1>
-        <a:srgbClr val="4F81BD"/>
+        <a:srgbClr val="FF5F05"/>
       </a:accent1>
       <a:accent2>
-        <a:srgbClr val="C0504D"/>
+        <a:srgbClr val="13294B"/>
       </a:accent2>
       <a:accent3>
-        <a:srgbClr val="9BBB59"/>
+        <a:srgbClr val="D94F04"/>
       </a:accent3>
       <a:accent4>
-        <a:srgbClr val="8064A2"/>
+        <a:srgbClr val="5B6E8C"/>
       </a:accent4>
       <a:accent5>
-        <a:srgbClr val="4BACC6"/>
+        <a:srgbClr val="9FB1C7"/>
       </a:accent5>
       <a:accent6>
-        <a:srgbClr val="F79646"/>
+        <a:srgbClr val="A5A5A5"/>
       </a:accent6>
       <a:hlink>
-        <a:srgbClr val="0000FF"/>
+        <a:srgbClr val="FF5F05"/>
       </a:hlink>
       <a:folHlink>
-        <a:srgbClr val="800080"/>
+        <a:srgbClr val="5B6E8C"/>
       </a:folHlink>
     </a:clrScheme>
-    <a:fontScheme name="Office">
+    <a:fontScheme name="Illinois">
       <a:majorFont>
-        <a:latin typeface="Calibri"/>
+        <a:latin typeface="Arial"/>
         <a:ea typeface=""/>
         <a:cs typeface=""/>
         <a:font script="Jpan" typeface="ＭＳ Ｐゴシック"/>
@@ -3153,7 +3569,7 @@
         <a:font script="Geor" typeface="Sylfaen"/>
       </a:majorFont>
       <a:minorFont>
-        <a:latin typeface="Calibri"/>
+        <a:latin typeface="Arial"/>
         <a:ea typeface=""/>
         <a:cs typeface=""/>
         <a:font script="Jpan" typeface="ＭＳ Ｐゴシック"/>

</xml_diff>